<commit_message>
adds a hint to exercise 1
</commit_message>
<xml_diff>
--- a/DevOps/Lesson 01 - Intro to Version Control/Intro to Version Control.pptx
+++ b/DevOps/Lesson 01 - Intro to Version Control/Intro to Version Control.pptx
@@ -5,7 +5,7 @@
     <p:sldMasterId id="2147483660" r:id="rId1"/>
   </p:sldMasterIdLst>
   <p:notesMasterIdLst>
-    <p:notesMasterId r:id="rId30"/>
+    <p:notesMasterId r:id="rId29"/>
   </p:notesMasterIdLst>
   <p:sldIdLst>
     <p:sldId id="256" r:id="rId2"/>
@@ -33,28 +33,27 @@
     <p:sldId id="271" r:id="rId24"/>
     <p:sldId id="272" r:id="rId25"/>
     <p:sldId id="273" r:id="rId26"/>
-    <p:sldId id="274" r:id="rId27"/>
+    <p:sldId id="276" r:id="rId27"/>
     <p:sldId id="275" r:id="rId28"/>
-    <p:sldId id="276" r:id="rId29"/>
   </p:sldIdLst>
   <p:sldSz cx="12192000" cy="6858000"/>
   <p:notesSz cx="6858000" cy="9144000"/>
   <p:embeddedFontLst>
     <p:embeddedFont>
       <p:font typeface="Arial Bold" panose="020B0704020202020204" pitchFamily="34" charset="0"/>
-      <p:bold r:id="rId31"/>
+      <p:bold r:id="rId30"/>
     </p:embeddedFont>
     <p:embeddedFont>
       <p:font typeface="Consolas" panose="020B0609020204030204" pitchFamily="49" charset="0"/>
-      <p:regular r:id="rId32"/>
-      <p:bold r:id="rId33"/>
-      <p:italic r:id="rId34"/>
-      <p:boldItalic r:id="rId35"/>
+      <p:regular r:id="rId31"/>
+      <p:bold r:id="rId32"/>
+      <p:italic r:id="rId33"/>
+      <p:boldItalic r:id="rId34"/>
     </p:embeddedFont>
     <p:embeddedFont>
       <p:font typeface="Play" panose="020B0604020202020204" charset="0"/>
-      <p:regular r:id="rId36"/>
-      <p:bold r:id="rId37"/>
+      <p:regular r:id="rId35"/>
+      <p:bold r:id="rId36"/>
     </p:embeddedFont>
   </p:embeddedFontLst>
   <p:defaultTextStyle>
@@ -2724,7 +2723,7 @@
   <p:cSld>
     <p:spTree>
       <p:nvGrpSpPr>
-        <p:cNvPr id="1" name="Shape 210"/>
+        <p:cNvPr id="1" name="Shape 224"/>
         <p:cNvGrpSpPr/>
         <p:nvPr/>
       </p:nvGrpSpPr>
@@ -2738,7 +2737,7 @@
       </p:grpSpPr>
       <p:sp>
         <p:nvSpPr>
-          <p:cNvPr id="211" name="Google Shape;211;p19:notes"/>
+          <p:cNvPr id="225" name="Google Shape;225;g370677852e4_0_0:notes"/>
           <p:cNvSpPr txBox="1">
             <a:spLocks noGrp="1"/>
           </p:cNvSpPr>
@@ -2749,7 +2748,7 @@
         <p:spPr>
           <a:xfrm>
             <a:off x="685800" y="4400550"/>
-            <a:ext cx="5486400" cy="3600450"/>
+            <a:ext cx="5486400" cy="3600600"/>
           </a:xfrm>
           <a:prstGeom prst="rect">
             <a:avLst/>
@@ -2776,7 +2775,7 @@
       </p:sp>
       <p:sp>
         <p:nvSpPr>
-          <p:cNvPr id="212" name="Google Shape;212;p19:notes"/>
+          <p:cNvPr id="226" name="Google Shape;226;g370677852e4_0_0:notes"/>
           <p:cNvSpPr>
             <a:spLocks noGrp="1" noRot="1" noChangeAspect="1"/>
           </p:cNvSpPr>
@@ -2985,110 +2984,6 @@
       <p:sp>
         <p:nvSpPr>
           <p:cNvPr id="218" name="Google Shape;218;p20:notes"/>
-          <p:cNvSpPr>
-            <a:spLocks noGrp="1" noRot="1" noChangeAspect="1"/>
-          </p:cNvSpPr>
-          <p:nvPr>
-            <p:ph type="sldImg" idx="2"/>
-          </p:nvPr>
-        </p:nvSpPr>
-        <p:spPr>
-          <a:xfrm>
-            <a:off x="685800" y="1143000"/>
-            <a:ext cx="5486400" cy="3086100"/>
-          </a:xfrm>
-          <a:custGeom>
-            <a:avLst/>
-            <a:gdLst/>
-            <a:ahLst/>
-            <a:cxnLst/>
-            <a:rect l="l" t="t" r="r" b="b"/>
-            <a:pathLst>
-              <a:path w="120000" h="120000" extrusionOk="0">
-                <a:moveTo>
-                  <a:pt x="0" y="0"/>
-                </a:moveTo>
-                <a:lnTo>
-                  <a:pt x="120000" y="0"/>
-                </a:lnTo>
-                <a:lnTo>
-                  <a:pt x="120000" y="120000"/>
-                </a:lnTo>
-                <a:lnTo>
-                  <a:pt x="0" y="120000"/>
-                </a:lnTo>
-                <a:close/>
-              </a:path>
-            </a:pathLst>
-          </a:custGeom>
-        </p:spPr>
-      </p:sp>
-    </p:spTree>
-  </p:cSld>
-  <p:clrMapOvr>
-    <a:masterClrMapping/>
-  </p:clrMapOvr>
-</p:notes>
-</file>
-
-<file path=ppt/notesSlides/notesSlide21.xml><?xml version="1.0" encoding="utf-8"?>
-<p:notes xmlns:a="http://schemas.openxmlformats.org/drawingml/2006/main" xmlns:r="http://schemas.openxmlformats.org/officeDocument/2006/relationships" xmlns:p="http://schemas.openxmlformats.org/presentationml/2006/main" showMasterSp="0" showMasterPhAnim="0">
-  <p:cSld>
-    <p:spTree>
-      <p:nvGrpSpPr>
-        <p:cNvPr id="1" name="Shape 224"/>
-        <p:cNvGrpSpPr/>
-        <p:nvPr/>
-      </p:nvGrpSpPr>
-      <p:grpSpPr>
-        <a:xfrm>
-          <a:off x="0" y="0"/>
-          <a:ext cx="0" cy="0"/>
-          <a:chOff x="0" y="0"/>
-          <a:chExt cx="0" cy="0"/>
-        </a:xfrm>
-      </p:grpSpPr>
-      <p:sp>
-        <p:nvSpPr>
-          <p:cNvPr id="225" name="Google Shape;225;g370677852e4_0_0:notes"/>
-          <p:cNvSpPr txBox="1">
-            <a:spLocks noGrp="1"/>
-          </p:cNvSpPr>
-          <p:nvPr>
-            <p:ph type="body" idx="1"/>
-          </p:nvPr>
-        </p:nvSpPr>
-        <p:spPr>
-          <a:xfrm>
-            <a:off x="685800" y="4400550"/>
-            <a:ext cx="5486400" cy="3600600"/>
-          </a:xfrm>
-          <a:prstGeom prst="rect">
-            <a:avLst/>
-          </a:prstGeom>
-        </p:spPr>
-        <p:txBody>
-          <a:bodyPr spcFirstLastPara="1" wrap="square" lIns="91425" tIns="45700" rIns="91425" bIns="45700" anchor="t" anchorCtr="0">
-            <a:noAutofit/>
-          </a:bodyPr>
-          <a:lstStyle/>
-          <a:p>
-            <a:pPr marL="0" lvl="0" indent="0" algn="l" rtl="0">
-              <a:spcBef>
-                <a:spcPts val="0"/>
-              </a:spcBef>
-              <a:spcAft>
-                <a:spcPts val="0"/>
-              </a:spcAft>
-              <a:buNone/>
-            </a:pPr>
-            <a:endParaRPr/>
-          </a:p>
-        </p:txBody>
-      </p:sp>
-      <p:sp>
-        <p:nvSpPr>
-          <p:cNvPr id="226" name="Google Shape;226;g370677852e4_0_0:notes"/>
           <p:cNvSpPr>
             <a:spLocks noGrp="1" noRot="1" noChangeAspect="1"/>
           </p:cNvSpPr>
@@ -4255,7 +4150,7 @@
           <a:p>
             <a:fld id="{7A3E0868-4E26-4CDC-8A56-D70E2D8B12FE}" type="datetime3">
               <a:rPr lang="en-US" smtClean="0"/>
-              <a:t>20 July 2026</a:t>
+              <a:t>22 July 2026</a:t>
             </a:fld>
             <a:endParaRPr lang="en-US"/>
           </a:p>
@@ -6816,7 +6711,7 @@
           <a:p>
             <a:fld id="{A7B8021B-6105-4216-96FC-94348F216D0E}" type="datetime3">
               <a:rPr lang="en-US" smtClean="0"/>
-              <a:t>20 July 2026</a:t>
+              <a:t>22 July 2026</a:t>
             </a:fld>
             <a:endParaRPr lang="en-US"/>
           </a:p>
@@ -8513,7 +8408,7 @@
           <a:p>
             <a:fld id="{5D27CFAB-73E6-44A8-B862-B3306344E3F2}" type="datetime3">
               <a:rPr lang="en-US" smtClean="0"/>
-              <a:t>20 July 2026</a:t>
+              <a:t>22 July 2026</a:t>
             </a:fld>
             <a:endParaRPr lang="en-US"/>
           </a:p>
@@ -10303,7 +10198,7 @@
           <a:p>
             <a:fld id="{A9B2E784-A5F5-4301-881B-94AC8DBF9DED}" type="datetime3">
               <a:rPr lang="en-US" smtClean="0"/>
-              <a:t>20 July 2026</a:t>
+              <a:t>22 July 2026</a:t>
             </a:fld>
             <a:endParaRPr lang="en-US"/>
           </a:p>
@@ -10482,7 +10377,7 @@
           <a:p>
             <a:fld id="{18EAB3A5-9E92-4BB9-8F22-9632B4FBEDBA}" type="datetime3">
               <a:rPr lang="en-US" smtClean="0"/>
-              <a:t>20 July 2026</a:t>
+              <a:t>22 July 2026</a:t>
             </a:fld>
             <a:endParaRPr lang="en-US"/>
           </a:p>
@@ -10709,7 +10604,7 @@
           <a:p>
             <a:fld id="{40923810-5FB2-48C9-96CA-1DE2C4773142}" type="datetime3">
               <a:rPr lang="en-US" smtClean="0"/>
-              <a:t>20 July 2026</a:t>
+              <a:t>22 July 2026</a:t>
             </a:fld>
             <a:endParaRPr lang="en-US"/>
           </a:p>
@@ -10999,7 +10894,7 @@
           <a:p>
             <a:fld id="{E50EFF4B-86EB-42FB-93EA-7D8F9CB2466F}" type="datetime3">
               <a:rPr lang="en-US" smtClean="0"/>
-              <a:t>20 July 2026</a:t>
+              <a:t>22 July 2026</a:t>
             </a:fld>
             <a:endParaRPr lang="en-US"/>
           </a:p>
@@ -11611,7 +11506,7 @@
           <a:p>
             <a:fld id="{FB14FC24-E041-45E9-9A72-E5755A86890F}" type="datetime3">
               <a:rPr lang="en-US" smtClean="0"/>
-              <a:t>20 July 2026</a:t>
+              <a:t>22 July 2026</a:t>
             </a:fld>
             <a:endParaRPr lang="en-US"/>
           </a:p>
@@ -12471,7 +12366,7 @@
           <a:p>
             <a:fld id="{98A19125-94A7-4474-858C-FD9C4ABE9DDA}" type="datetime3">
               <a:rPr lang="en-US" smtClean="0"/>
-              <a:t>20 July 2026</a:t>
+              <a:t>22 July 2026</a:t>
             </a:fld>
             <a:endParaRPr lang="en-US"/>
           </a:p>
@@ -13574,7 +13469,7 @@
           <a:p>
             <a:fld id="{3BA0343D-C8D8-43CE-BB79-50DEA219DB07}" type="datetime3">
               <a:rPr lang="en-US" smtClean="0"/>
-              <a:t>20 July 2026</a:t>
+              <a:t>22 July 2026</a:t>
             </a:fld>
             <a:endParaRPr lang="en-US"/>
           </a:p>
@@ -13863,7 +13758,7 @@
           <a:p>
             <a:fld id="{453BD212-0B9F-4987-965F-AC83B2FC354F}" type="datetime3">
               <a:rPr lang="en-US" smtClean="0"/>
-              <a:t>20 July 2026</a:t>
+              <a:t>22 July 2026</a:t>
             </a:fld>
             <a:endParaRPr lang="en-US"/>
           </a:p>
@@ -14108,7 +14003,7 @@
           <a:p>
             <a:fld id="{6DDC931E-8CBE-4A3F-A034-9B6122C6DCDB}" type="datetime3">
               <a:rPr lang="en-US" smtClean="0"/>
-              <a:t>20 July 2026</a:t>
+              <a:t>22 July 2026</a:t>
             </a:fld>
             <a:endParaRPr lang="en-US"/>
           </a:p>
@@ -15874,7 +15769,7 @@
           <a:p>
             <a:fld id="{220AF9C2-5E8A-4308-AE6B-CA9B65007D0E}" type="datetime3">
               <a:rPr lang="en-US" smtClean="0"/>
-              <a:t>20 July 2026</a:t>
+              <a:t>22 July 2026</a:t>
             </a:fld>
             <a:endParaRPr lang="en-US"/>
           </a:p>
@@ -16187,7 +16082,7 @@
           <a:p>
             <a:fld id="{FF31E861-D2AF-431D-860B-DCF67C218052}" type="datetime3">
               <a:rPr lang="en-US" smtClean="0"/>
-              <a:t>20 July 2026</a:t>
+              <a:t>22 July 2026</a:t>
             </a:fld>
             <a:endParaRPr lang="en-US"/>
           </a:p>
@@ -16466,7 +16361,7 @@
           <a:p>
             <a:fld id="{D1DA25B2-AAF1-4C1F-AA38-12D5BFA7D4C8}" type="datetime3">
               <a:rPr lang="en-US" smtClean="0"/>
-              <a:t>20 July 2026</a:t>
+              <a:t>22 July 2026</a:t>
             </a:fld>
             <a:endParaRPr lang="en-US"/>
           </a:p>
@@ -16745,7 +16640,7 @@
           <a:p>
             <a:fld id="{A25C0F39-45D0-48E9-90B3-7FE8FCE561C8}" type="datetime3">
               <a:rPr lang="en-US" smtClean="0"/>
-              <a:t>20 July 2026</a:t>
+              <a:t>22 July 2026</a:t>
             </a:fld>
             <a:endParaRPr lang="en-US"/>
           </a:p>
@@ -17246,7 +17141,7 @@
           <a:p>
             <a:fld id="{9BAF1A3D-92FA-4F24-9781-74AFA516A230}" type="datetime3">
               <a:rPr lang="en-US" smtClean="0"/>
-              <a:t>20 July 2026</a:t>
+              <a:t>22 July 2026</a:t>
             </a:fld>
             <a:endParaRPr lang="en-US"/>
           </a:p>
@@ -17373,7 +17268,7 @@
           <a:p>
             <a:fld id="{5719C672-856D-4617-A693-8FE15749A9B7}" type="datetime3">
               <a:rPr lang="en-US" smtClean="0"/>
-              <a:t>20 July 2026</a:t>
+              <a:t>22 July 2026</a:t>
             </a:fld>
             <a:endParaRPr lang="en-US"/>
           </a:p>
@@ -17508,7 +17403,7 @@
           <a:p>
             <a:fld id="{5F6C764D-A39E-4C03-B161-E0BC66E8883B}" type="datetime3">
               <a:rPr lang="en-US" smtClean="0"/>
-              <a:t>20 July 2026</a:t>
+              <a:t>22 July 2026</a:t>
             </a:fld>
             <a:endParaRPr lang="en-US"/>
           </a:p>
@@ -17750,7 +17645,7 @@
           <a:p>
             <a:fld id="{6E3E33F9-20B7-4995-BE7D-165DBB597850}" type="datetime3">
               <a:rPr lang="en-US" smtClean="0"/>
-              <a:t>20 July 2026</a:t>
+              <a:t>22 July 2026</a:t>
             </a:fld>
             <a:endParaRPr lang="en-US"/>
           </a:p>
@@ -17863,7 +17758,7 @@
           <a:p>
             <a:fld id="{CD41C263-3501-4369-A962-62B6BF915CDE}" type="datetime3">
               <a:rPr lang="en-US" smtClean="0"/>
-              <a:t>20 July 2026</a:t>
+              <a:t>22 July 2026</a:t>
             </a:fld>
             <a:endParaRPr lang="en-US"/>
           </a:p>
@@ -18266,7 +18161,7 @@
           <a:p>
             <a:fld id="{B06F3EBE-B2E8-4992-9F00-9E4B44F057C0}" type="datetime3">
               <a:rPr lang="en-US" smtClean="0"/>
-              <a:t>20 July 2026</a:t>
+              <a:t>22 July 2026</a:t>
             </a:fld>
             <a:endParaRPr lang="en-US"/>
           </a:p>
@@ -18398,7 +18293,7 @@
           <a:p>
             <a:fld id="{D41656AB-D2E1-472E-8B95-0DF5C6E1D623}" type="datetime3">
               <a:rPr lang="en-US" smtClean="0"/>
-              <a:t>20 July 2026</a:t>
+              <a:t>22 July 2026</a:t>
             </a:fld>
             <a:endParaRPr lang="en-US"/>
           </a:p>
@@ -25647,7 +25542,7 @@
           <a:p>
             <a:fld id="{AD622D1A-DF83-41A8-85FF-04D90BF831D3}" type="datetime3">
               <a:rPr lang="en-US" smtClean="0"/>
-              <a:t>20 July 2026</a:t>
+              <a:t>22 July 2026</a:t>
             </a:fld>
             <a:endParaRPr lang="en-US"/>
           </a:p>
@@ -25897,7 +25792,7 @@
           <a:p>
             <a:fld id="{334F72C3-CDF3-44A8-B602-1649B1728485}" type="datetime3">
               <a:rPr lang="en-US" smtClean="0"/>
-              <a:t>20 July 2026</a:t>
+              <a:t>22 July 2026</a:t>
             </a:fld>
             <a:endParaRPr lang="en-US"/>
           </a:p>
@@ -26204,7 +26099,7 @@
           <a:p>
             <a:fld id="{1E0132BA-B5E7-4FFD-AF6C-169169D47D4A}" type="datetime3">
               <a:rPr lang="en-US" smtClean="0"/>
-              <a:t>20 July 2026</a:t>
+              <a:t>22 July 2026</a:t>
             </a:fld>
             <a:endParaRPr lang="en-US"/>
           </a:p>
@@ -26685,7 +26580,7 @@
           <a:p>
             <a:fld id="{81A30091-1C2A-4151-8D3C-D1E47A72615F}" type="datetime3">
               <a:rPr lang="en-US" smtClean="0"/>
-              <a:t>20 July 2026</a:t>
+              <a:t>22 July 2026</a:t>
             </a:fld>
             <a:endParaRPr lang="en-US"/>
           </a:p>
@@ -27322,7 +27217,7 @@
           <a:p>
             <a:fld id="{35D703CE-07B4-4C05-A488-B4566700621F}" type="datetime3">
               <a:rPr lang="en-US" smtClean="0"/>
-              <a:t>20 July 2026</a:t>
+              <a:t>22 July 2026</a:t>
             </a:fld>
             <a:endParaRPr lang="en-US"/>
           </a:p>
@@ -28380,7 +28275,7 @@
           <a:p>
             <a:fld id="{694BD61C-20BA-43AF-A21F-1DAFB3200099}" type="datetime3">
               <a:rPr lang="en-US" smtClean="0"/>
-              <a:t>20 July 2026</a:t>
+              <a:t>22 July 2026</a:t>
             </a:fld>
             <a:endParaRPr lang="en-US"/>
           </a:p>
@@ -28867,7 +28762,7 @@
           <a:p>
             <a:fld id="{CABCB1B0-B6E5-4DD1-BB55-95C076D6C0C8}" type="datetime3">
               <a:rPr lang="en-US" smtClean="0"/>
-              <a:t>20 July 2026</a:t>
+              <a:t>22 July 2026</a:t>
             </a:fld>
             <a:endParaRPr lang="en-US"/>
           </a:p>
@@ -29822,7 +29717,7 @@
           <a:p>
             <a:fld id="{AD622D1A-DF83-41A8-85FF-04D90BF831D3}" type="datetime3">
               <a:rPr lang="en-US" smtClean="0"/>
-              <a:t>20 July 2026</a:t>
+              <a:t>22 July 2026</a:t>
             </a:fld>
             <a:endParaRPr lang="en-US"/>
           </a:p>
@@ -33530,7 +33425,7 @@
           <a:p>
             <a:fld id="{AD622D1A-DF83-41A8-85FF-04D90BF831D3}" type="datetime3">
               <a:rPr lang="en-US" smtClean="0"/>
-              <a:t>20 July 2026</a:t>
+              <a:t>22 July 2026</a:t>
             </a:fld>
             <a:endParaRPr lang="en-US"/>
           </a:p>
@@ -40210,7 +40105,7 @@
           <a:p>
             <a:fld id="{AD622D1A-DF83-41A8-85FF-04D90BF831D3}" type="datetime3">
               <a:rPr lang="en-US" smtClean="0"/>
-              <a:t>20 July 2026</a:t>
+              <a:t>22 July 2026</a:t>
             </a:fld>
             <a:endParaRPr lang="en-US"/>
           </a:p>
@@ -41193,104 +41088,6 @@
                                     <p:set>
                                       <p:cBhvr>
                                         <p:cTn id="22" dur="1" fill="hold">
-                                          <p:stCondLst>
-                                            <p:cond delay="0"/>
-                                          </p:stCondLst>
-                                        </p:cTn>
-                                        <p:tgtEl>
-                                          <p:spTgt spid="154">
-                                            <p:txEl>
-                                              <p:pRg st="4" end="4"/>
-                                            </p:txEl>
-                                          </p:spTgt>
-                                        </p:tgtEl>
-                                        <p:attrNameLst>
-                                          <p:attrName>style.visibility</p:attrName>
-                                        </p:attrNameLst>
-                                      </p:cBhvr>
-                                      <p:to>
-                                        <p:strVal val="visible"/>
-                                      </p:to>
-                                    </p:set>
-                                  </p:childTnLst>
-                                </p:cTn>
-                              </p:par>
-                            </p:childTnLst>
-                          </p:cTn>
-                        </p:par>
-                      </p:childTnLst>
-                    </p:cTn>
-                  </p:par>
-                  <p:par>
-                    <p:cTn id="23" fill="hold">
-                      <p:stCondLst>
-                        <p:cond delay="indefinite"/>
-                      </p:stCondLst>
-                      <p:childTnLst>
-                        <p:par>
-                          <p:cTn id="24" fill="hold">
-                            <p:stCondLst>
-                              <p:cond delay="0"/>
-                            </p:stCondLst>
-                            <p:childTnLst>
-                              <p:par>
-                                <p:cTn id="25" presetID="1" presetClass="entr" presetSubtype="0" fill="hold" nodeType="clickEffect">
-                                  <p:stCondLst>
-                                    <p:cond delay="0"/>
-                                  </p:stCondLst>
-                                  <p:childTnLst>
-                                    <p:set>
-                                      <p:cBhvr>
-                                        <p:cTn id="26" dur="1" fill="hold">
-                                          <p:stCondLst>
-                                            <p:cond delay="0"/>
-                                          </p:stCondLst>
-                                        </p:cTn>
-                                        <p:tgtEl>
-                                          <p:spTgt spid="154">
-                                            <p:txEl>
-                                              <p:pRg st="5" end="5"/>
-                                            </p:txEl>
-                                          </p:spTgt>
-                                        </p:tgtEl>
-                                        <p:attrNameLst>
-                                          <p:attrName>style.visibility</p:attrName>
-                                        </p:attrNameLst>
-                                      </p:cBhvr>
-                                      <p:to>
-                                        <p:strVal val="visible"/>
-                                      </p:to>
-                                    </p:set>
-                                  </p:childTnLst>
-                                </p:cTn>
-                              </p:par>
-                            </p:childTnLst>
-                          </p:cTn>
-                        </p:par>
-                      </p:childTnLst>
-                    </p:cTn>
-                  </p:par>
-                  <p:par>
-                    <p:cTn id="27" fill="hold">
-                      <p:stCondLst>
-                        <p:cond delay="indefinite"/>
-                      </p:stCondLst>
-                      <p:childTnLst>
-                        <p:par>
-                          <p:cTn id="28" fill="hold">
-                            <p:stCondLst>
-                              <p:cond delay="0"/>
-                            </p:stCondLst>
-                            <p:childTnLst>
-                              <p:par>
-                                <p:cTn id="29" presetID="1" presetClass="entr" presetSubtype="0" fill="hold" nodeType="clickEffect">
-                                  <p:stCondLst>
-                                    <p:cond delay="0"/>
-                                  </p:stCondLst>
-                                  <p:childTnLst>
-                                    <p:set>
-                                      <p:cBhvr>
-                                        <p:cTn id="30" dur="1" fill="hold">
                                           <p:stCondLst>
                                             <p:cond delay="0"/>
                                           </p:stCondLst>
@@ -45130,7 +44927,7 @@
   <p:cSld>
     <p:spTree>
       <p:nvGrpSpPr>
-        <p:cNvPr id="1" name="Shape 213"/>
+        <p:cNvPr id="1" name="Shape 227"/>
         <p:cNvGrpSpPr/>
         <p:nvPr/>
       </p:nvGrpSpPr>
@@ -45144,7 +44941,7 @@
       </p:grpSpPr>
       <p:sp>
         <p:nvSpPr>
-          <p:cNvPr id="214" name="Google Shape;214;p31"/>
+          <p:cNvPr id="228" name="Google Shape;228;p33"/>
           <p:cNvSpPr txBox="1">
             <a:spLocks noGrp="1"/>
           </p:cNvSpPr>
@@ -45162,8 +44959,8 @@
           </a:ln>
         </p:spPr>
         <p:txBody>
-          <a:bodyPr spcFirstLastPara="1" wrap="square" lIns="91425" tIns="45700" rIns="91425" bIns="45700" anchor="ctr" anchorCtr="0">
-            <a:normAutofit/>
+          <a:bodyPr spcFirstLastPara="1" wrap="square" lIns="91425" tIns="45700" rIns="91425" bIns="45700" anchor="b" anchorCtr="0">
+            <a:normAutofit fontScale="90000"/>
           </a:bodyPr>
           <a:lstStyle/>
           <a:p>
@@ -45180,13 +44977,13 @@
               <a:buClr>
                 <a:schemeClr val="dk1"/>
               </a:buClr>
-              <a:buSzPts val="4400"/>
+              <a:buSzPts val="3200"/>
               <a:buFont typeface="Play"/>
               <a:buNone/>
             </a:pPr>
             <a:r>
               <a:rPr lang="en-US"/>
-              <a:t>Why the command line???</a:t>
+              <a:t>Other Resources (HIGHLY RECOMMEND)</a:t>
             </a:r>
             <a:endParaRPr/>
           </a:p>
@@ -45194,7 +44991,7 @@
       </p:sp>
       <p:sp>
         <p:nvSpPr>
-          <p:cNvPr id="215" name="Google Shape;215;p31"/>
+          <p:cNvPr id="229" name="Google Shape;229;p33"/>
           <p:cNvSpPr txBox="1">
             <a:spLocks noGrp="1"/>
           </p:cNvSpPr>
@@ -45203,13 +45000,13 @@
           </p:nvPr>
         </p:nvSpPr>
         <p:spPr>
+          <a:xfrm>
+            <a:off x="838200" y="1756750"/>
+            <a:ext cx="10515600" cy="4351200"/>
+          </a:xfrm>
           <a:prstGeom prst="rect">
             <a:avLst/>
           </a:prstGeom>
-          <a:noFill/>
-          <a:ln>
-            <a:noFill/>
-          </a:ln>
         </p:spPr>
         <p:txBody>
           <a:bodyPr spcFirstLastPara="1" wrap="square" lIns="91425" tIns="45700" rIns="91425" bIns="45700" anchor="t" anchorCtr="0">
@@ -45217,10 +45014,40 @@
           </a:bodyPr>
           <a:lstStyle/>
           <a:p>
-            <a:pPr marL="228600" lvl="0" indent="-228600" algn="l" rtl="0">
-              <a:lnSpc>
-                <a:spcPct val="90000"/>
-              </a:lnSpc>
+            <a:pPr marL="0" lvl="0" indent="0" algn="l" rtl="0">
+              <a:spcBef>
+                <a:spcPts val="0"/>
+              </a:spcBef>
+              <a:spcAft>
+                <a:spcPts val="0"/>
+              </a:spcAft>
+              <a:buNone/>
+            </a:pPr>
+            <a:endParaRPr sz="3200"/>
+          </a:p>
+          <a:p>
+            <a:pPr marL="0" lvl="0" indent="0" algn="l" rtl="0">
+              <a:spcBef>
+                <a:spcPts val="0"/>
+              </a:spcBef>
+              <a:spcAft>
+                <a:spcPts val="0"/>
+              </a:spcAft>
+              <a:buNone/>
+            </a:pPr>
+            <a:r>
+              <a:rPr lang="en-US" sz="2400" u="sng">
+                <a:solidFill>
+                  <a:schemeClr val="hlink"/>
+                </a:solidFill>
+                <a:hlinkClick r:id="rId3"/>
+              </a:rPr>
+              <a:t>Oh My Git!</a:t>
+            </a:r>
+            <a:endParaRPr sz="3200"/>
+          </a:p>
+          <a:p>
+            <a:pPr marL="0" lvl="0" indent="0" algn="l" rtl="0">
               <a:spcBef>
                 <a:spcPts val="0"/>
               </a:spcBef>
@@ -45230,22 +45057,49 @@
               <a:buClr>
                 <a:schemeClr val="dk1"/>
               </a:buClr>
-              <a:buSzPts val="2800"/>
-              <a:buChar char="•"/>
+              <a:buSzPts val="1100"/>
+              <a:buFont typeface="Arial"/>
+              <a:buNone/>
             </a:pPr>
-            <a:r>
-              <a:rPr lang="en-US"/>
-              <a:t>Good practice using terminals</a:t>
-            </a:r>
-            <a:endParaRPr/>
-          </a:p>
-          <a:p>
-            <a:pPr marL="228600" lvl="0" indent="-228600" algn="l" rtl="0">
-              <a:lnSpc>
-                <a:spcPct val="90000"/>
-              </a:lnSpc>
-              <a:spcBef>
-                <a:spcPts val="1000"/>
+            <a:endParaRPr sz="3200"/>
+          </a:p>
+          <a:p>
+            <a:pPr marL="0" lvl="0" indent="0" algn="l" rtl="0">
+              <a:spcBef>
+                <a:spcPts val="0"/>
+              </a:spcBef>
+              <a:spcAft>
+                <a:spcPts val="0"/>
+              </a:spcAft>
+              <a:buNone/>
+            </a:pPr>
+            <a:r>
+              <a:rPr lang="en-US" sz="2200" u="sng">
+                <a:solidFill>
+                  <a:schemeClr val="hlink"/>
+                </a:solidFill>
+                <a:hlinkClick r:id="rId4"/>
+              </a:rPr>
+              <a:t>Learn Git Branching</a:t>
+            </a:r>
+            <a:endParaRPr sz="3900"/>
+          </a:p>
+          <a:p>
+            <a:pPr marL="0" lvl="0" indent="0" algn="l" rtl="0">
+              <a:spcBef>
+                <a:spcPts val="0"/>
+              </a:spcBef>
+              <a:spcAft>
+                <a:spcPts val="0"/>
+              </a:spcAft>
+              <a:buNone/>
+            </a:pPr>
+            <a:endParaRPr sz="3500"/>
+          </a:p>
+          <a:p>
+            <a:pPr marL="0" lvl="0" indent="0" algn="l" rtl="0">
+              <a:spcBef>
+                <a:spcPts val="0"/>
               </a:spcBef>
               <a:spcAft>
                 <a:spcPts val="0"/>
@@ -45253,82 +45107,22 @@
               <a:buClr>
                 <a:schemeClr val="dk1"/>
               </a:buClr>
-              <a:buSzPts val="2800"/>
-              <a:buChar char="•"/>
+              <a:buSzPts val="1600"/>
+              <a:buFont typeface="Arial"/>
+              <a:buNone/>
             </a:pPr>
-            <a:r>
-              <a:rPr lang="en-US"/>
-              <a:t>Not every UI exposes all the commands</a:t>
-            </a:r>
-            <a:endParaRPr/>
-          </a:p>
-          <a:p>
-            <a:pPr marL="228600" lvl="0" indent="-228600" algn="l" rtl="0">
-              <a:lnSpc>
-                <a:spcPct val="90000"/>
-              </a:lnSpc>
+            <a:endParaRPr sz="4400"/>
+          </a:p>
+          <a:p>
+            <a:pPr marL="0" lvl="0" indent="0" algn="l" rtl="0">
               <a:spcBef>
                 <a:spcPts val="1000"/>
               </a:spcBef>
               <a:spcAft>
                 <a:spcPts val="0"/>
               </a:spcAft>
-              <a:buClr>
-                <a:schemeClr val="dk1"/>
-              </a:buClr>
-              <a:buSzPts val="2800"/>
-              <a:buChar char="•"/>
+              <a:buNone/>
             </a:pPr>
-            <a:r>
-              <a:rPr lang="en-US"/>
-              <a:t>Most servers are terminal-only</a:t>
-            </a:r>
-            <a:endParaRPr/>
-          </a:p>
-          <a:p>
-            <a:pPr marL="228600" lvl="0" indent="-228600" algn="l" rtl="0">
-              <a:lnSpc>
-                <a:spcPct val="90000"/>
-              </a:lnSpc>
-              <a:spcBef>
-                <a:spcPts val="1000"/>
-              </a:spcBef>
-              <a:spcAft>
-                <a:spcPts val="0"/>
-              </a:spcAft>
-              <a:buClr>
-                <a:schemeClr val="dk1"/>
-              </a:buClr>
-              <a:buSzPts val="2800"/>
-              <a:buChar char="•"/>
-            </a:pPr>
-            <a:r>
-              <a:rPr lang="en-US"/>
-              <a:t>Using commands allows us to automate / script / chain</a:t>
-            </a:r>
-            <a:endParaRPr/>
-          </a:p>
-          <a:p>
-            <a:pPr marL="228600" lvl="0" indent="-228600" algn="l" rtl="0">
-              <a:lnSpc>
-                <a:spcPct val="90000"/>
-              </a:lnSpc>
-              <a:spcBef>
-                <a:spcPts val="1000"/>
-              </a:spcBef>
-              <a:spcAft>
-                <a:spcPts val="0"/>
-              </a:spcAft>
-              <a:buClr>
-                <a:schemeClr val="dk1"/>
-              </a:buClr>
-              <a:buSzPts val="2800"/>
-              <a:buChar char="•"/>
-            </a:pPr>
-            <a:r>
-              <a:rPr lang="en-US"/>
-              <a:t>Reading documentation for command-line utilities is an art…</a:t>
-            </a:r>
             <a:endParaRPr/>
           </a:p>
         </p:txBody>
@@ -45593,219 +45387,6 @@
 </p:sld>
 </file>
 
-<file path=ppt/slides/slide28.xml><?xml version="1.0" encoding="utf-8"?>
-<p:sld xmlns:a="http://schemas.openxmlformats.org/drawingml/2006/main" xmlns:r="http://schemas.openxmlformats.org/officeDocument/2006/relationships" xmlns:p="http://schemas.openxmlformats.org/presentationml/2006/main">
-  <p:cSld>
-    <p:spTree>
-      <p:nvGrpSpPr>
-        <p:cNvPr id="1" name="Shape 227"/>
-        <p:cNvGrpSpPr/>
-        <p:nvPr/>
-      </p:nvGrpSpPr>
-      <p:grpSpPr>
-        <a:xfrm>
-          <a:off x="0" y="0"/>
-          <a:ext cx="0" cy="0"/>
-          <a:chOff x="0" y="0"/>
-          <a:chExt cx="0" cy="0"/>
-        </a:xfrm>
-      </p:grpSpPr>
-      <p:sp>
-        <p:nvSpPr>
-          <p:cNvPr id="228" name="Google Shape;228;p33"/>
-          <p:cNvSpPr txBox="1">
-            <a:spLocks noGrp="1"/>
-          </p:cNvSpPr>
-          <p:nvPr>
-            <p:ph type="title"/>
-          </p:nvPr>
-        </p:nvSpPr>
-        <p:spPr>
-          <a:prstGeom prst="rect">
-            <a:avLst/>
-          </a:prstGeom>
-          <a:noFill/>
-          <a:ln>
-            <a:noFill/>
-          </a:ln>
-        </p:spPr>
-        <p:txBody>
-          <a:bodyPr spcFirstLastPara="1" wrap="square" lIns="91425" tIns="45700" rIns="91425" bIns="45700" anchor="b" anchorCtr="0">
-            <a:normAutofit fontScale="90000"/>
-          </a:bodyPr>
-          <a:lstStyle/>
-          <a:p>
-            <a:pPr marL="0" lvl="0" indent="0" algn="l" rtl="0">
-              <a:lnSpc>
-                <a:spcPct val="90000"/>
-              </a:lnSpc>
-              <a:spcBef>
-                <a:spcPts val="0"/>
-              </a:spcBef>
-              <a:spcAft>
-                <a:spcPts val="0"/>
-              </a:spcAft>
-              <a:buClr>
-                <a:schemeClr val="dk1"/>
-              </a:buClr>
-              <a:buSzPts val="3200"/>
-              <a:buFont typeface="Play"/>
-              <a:buNone/>
-            </a:pPr>
-            <a:r>
-              <a:rPr lang="en-US"/>
-              <a:t>Other Resources (HIGHLY RECOMMEND)</a:t>
-            </a:r>
-            <a:endParaRPr/>
-          </a:p>
-        </p:txBody>
-      </p:sp>
-      <p:sp>
-        <p:nvSpPr>
-          <p:cNvPr id="229" name="Google Shape;229;p33"/>
-          <p:cNvSpPr txBox="1">
-            <a:spLocks noGrp="1"/>
-          </p:cNvSpPr>
-          <p:nvPr>
-            <p:ph idx="1"/>
-          </p:nvPr>
-        </p:nvSpPr>
-        <p:spPr>
-          <a:xfrm>
-            <a:off x="838200" y="1756750"/>
-            <a:ext cx="10515600" cy="4351200"/>
-          </a:xfrm>
-          <a:prstGeom prst="rect">
-            <a:avLst/>
-          </a:prstGeom>
-        </p:spPr>
-        <p:txBody>
-          <a:bodyPr spcFirstLastPara="1" wrap="square" lIns="91425" tIns="45700" rIns="91425" bIns="45700" anchor="t" anchorCtr="0">
-            <a:normAutofit/>
-          </a:bodyPr>
-          <a:lstStyle/>
-          <a:p>
-            <a:pPr marL="0" lvl="0" indent="0" algn="l" rtl="0">
-              <a:spcBef>
-                <a:spcPts val="0"/>
-              </a:spcBef>
-              <a:spcAft>
-                <a:spcPts val="0"/>
-              </a:spcAft>
-              <a:buNone/>
-            </a:pPr>
-            <a:endParaRPr sz="3200"/>
-          </a:p>
-          <a:p>
-            <a:pPr marL="0" lvl="0" indent="0" algn="l" rtl="0">
-              <a:spcBef>
-                <a:spcPts val="0"/>
-              </a:spcBef>
-              <a:spcAft>
-                <a:spcPts val="0"/>
-              </a:spcAft>
-              <a:buNone/>
-            </a:pPr>
-            <a:r>
-              <a:rPr lang="en-US" sz="2400" u="sng">
-                <a:solidFill>
-                  <a:schemeClr val="hlink"/>
-                </a:solidFill>
-                <a:hlinkClick r:id="rId3"/>
-              </a:rPr>
-              <a:t>Oh My Git!</a:t>
-            </a:r>
-            <a:endParaRPr sz="3200"/>
-          </a:p>
-          <a:p>
-            <a:pPr marL="0" lvl="0" indent="0" algn="l" rtl="0">
-              <a:spcBef>
-                <a:spcPts val="0"/>
-              </a:spcBef>
-              <a:spcAft>
-                <a:spcPts val="0"/>
-              </a:spcAft>
-              <a:buClr>
-                <a:schemeClr val="dk1"/>
-              </a:buClr>
-              <a:buSzPts val="1100"/>
-              <a:buFont typeface="Arial"/>
-              <a:buNone/>
-            </a:pPr>
-            <a:endParaRPr sz="3200"/>
-          </a:p>
-          <a:p>
-            <a:pPr marL="0" lvl="0" indent="0" algn="l" rtl="0">
-              <a:spcBef>
-                <a:spcPts val="0"/>
-              </a:spcBef>
-              <a:spcAft>
-                <a:spcPts val="0"/>
-              </a:spcAft>
-              <a:buNone/>
-            </a:pPr>
-            <a:r>
-              <a:rPr lang="en-US" sz="2200" u="sng">
-                <a:solidFill>
-                  <a:schemeClr val="hlink"/>
-                </a:solidFill>
-                <a:hlinkClick r:id="rId4"/>
-              </a:rPr>
-              <a:t>Learn Git Branching</a:t>
-            </a:r>
-            <a:endParaRPr sz="3900"/>
-          </a:p>
-          <a:p>
-            <a:pPr marL="0" lvl="0" indent="0" algn="l" rtl="0">
-              <a:spcBef>
-                <a:spcPts val="0"/>
-              </a:spcBef>
-              <a:spcAft>
-                <a:spcPts val="0"/>
-              </a:spcAft>
-              <a:buNone/>
-            </a:pPr>
-            <a:endParaRPr sz="3500"/>
-          </a:p>
-          <a:p>
-            <a:pPr marL="0" lvl="0" indent="0" algn="l" rtl="0">
-              <a:spcBef>
-                <a:spcPts val="0"/>
-              </a:spcBef>
-              <a:spcAft>
-                <a:spcPts val="0"/>
-              </a:spcAft>
-              <a:buClr>
-                <a:schemeClr val="dk1"/>
-              </a:buClr>
-              <a:buSzPts val="1600"/>
-              <a:buFont typeface="Arial"/>
-              <a:buNone/>
-            </a:pPr>
-            <a:endParaRPr sz="4400"/>
-          </a:p>
-          <a:p>
-            <a:pPr marL="0" lvl="0" indent="0" algn="l" rtl="0">
-              <a:spcBef>
-                <a:spcPts val="1000"/>
-              </a:spcBef>
-              <a:spcAft>
-                <a:spcPts val="0"/>
-              </a:spcAft>
-              <a:buNone/>
-            </a:pPr>
-            <a:endParaRPr/>
-          </a:p>
-        </p:txBody>
-      </p:sp>
-    </p:spTree>
-  </p:cSld>
-  <p:clrMapOvr>
-    <a:masterClrMapping/>
-  </p:clrMapOvr>
-</p:sld>
-</file>
-
 <file path=ppt/slides/slide3.xml><?xml version="1.0" encoding="utf-8"?>
 <p:sld xmlns:a="http://schemas.openxmlformats.org/drawingml/2006/main" xmlns:r="http://schemas.openxmlformats.org/officeDocument/2006/relationships" xmlns:p="http://schemas.openxmlformats.org/presentationml/2006/main">
   <p:cSld>
@@ -46978,7 +46559,7 @@
           <a:p>
             <a:fld id="{AD622D1A-DF83-41A8-85FF-04D90BF831D3}" type="datetime3">
               <a:rPr lang="en-US" smtClean="0"/>
-              <a:t>20 July 2026</a:t>
+              <a:t>22 July 2026</a:t>
             </a:fld>
             <a:endParaRPr lang="en-US"/>
           </a:p>
@@ -49517,7 +49098,7 @@
           <a:p>
             <a:fld id="{AD622D1A-DF83-41A8-85FF-04D90BF831D3}" type="datetime3">
               <a:rPr lang="en-US" smtClean="0"/>
-              <a:t>20 July 2026</a:t>
+              <a:t>22 July 2026</a:t>
             </a:fld>
             <a:endParaRPr lang="en-US"/>
           </a:p>
@@ -50859,7 +50440,7 @@
           <a:p>
             <a:fld id="{AD622D1A-DF83-41A8-85FF-04D90BF831D3}" type="datetime3">
               <a:rPr lang="en-US" smtClean="0"/>
-              <a:t>20 July 2026</a:t>
+              <a:t>22 July 2026</a:t>
             </a:fld>
             <a:endParaRPr lang="en-US"/>
           </a:p>

</xml_diff>